<commit_message>
G06 - Commit with late logic creation
</commit_message>
<xml_diff>
--- a/Generations/G06/doc/G06_slides.pptx
+++ b/Generations/G06/doc/G06_slides.pptx
@@ -262,7 +262,7 @@
           <a:p>
             <a:fld id="{2C01C9F1-F29D-274D-A784-FAA5CFF8E267}" type="datetimeFigureOut">
               <a:rPr lang="en-HU" smtClean="0"/>
-              <a:t>2025. 08. 12.</a:t>
+              <a:t>2025. 08. 27.</a:t>
             </a:fld>
             <a:endParaRPr lang="en-HU"/>
           </a:p>
@@ -462,7 +462,7 @@
           <a:p>
             <a:fld id="{2C01C9F1-F29D-274D-A784-FAA5CFF8E267}" type="datetimeFigureOut">
               <a:rPr lang="en-HU" smtClean="0"/>
-              <a:t>2025. 08. 13.</a:t>
+              <a:t>2025. 08. 27.</a:t>
             </a:fld>
             <a:endParaRPr lang="en-HU"/>
           </a:p>
@@ -672,7 +672,7 @@
           <a:p>
             <a:fld id="{2C01C9F1-F29D-274D-A784-FAA5CFF8E267}" type="datetimeFigureOut">
               <a:rPr lang="en-HU" smtClean="0"/>
-              <a:t>2025. 08. 13.</a:t>
+              <a:t>2025. 08. 27.</a:t>
             </a:fld>
             <a:endParaRPr lang="en-HU"/>
           </a:p>
@@ -872,7 +872,7 @@
           <a:p>
             <a:fld id="{2C01C9F1-F29D-274D-A784-FAA5CFF8E267}" type="datetimeFigureOut">
               <a:rPr lang="en-HU" smtClean="0"/>
-              <a:t>2025. 08. 13.</a:t>
+              <a:t>2025. 08. 27.</a:t>
             </a:fld>
             <a:endParaRPr lang="en-HU"/>
           </a:p>
@@ -1148,7 +1148,7 @@
           <a:p>
             <a:fld id="{2C01C9F1-F29D-274D-A784-FAA5CFF8E267}" type="datetimeFigureOut">
               <a:rPr lang="en-HU" smtClean="0"/>
-              <a:t>2025. 08. 13.</a:t>
+              <a:t>2025. 08. 27.</a:t>
             </a:fld>
             <a:endParaRPr lang="en-HU"/>
           </a:p>
@@ -1416,7 +1416,7 @@
           <a:p>
             <a:fld id="{2C01C9F1-F29D-274D-A784-FAA5CFF8E267}" type="datetimeFigureOut">
               <a:rPr lang="en-HU" smtClean="0"/>
-              <a:t>2025. 08. 13.</a:t>
+              <a:t>2025. 08. 27.</a:t>
             </a:fld>
             <a:endParaRPr lang="en-HU"/>
           </a:p>
@@ -1831,7 +1831,7 @@
           <a:p>
             <a:fld id="{2C01C9F1-F29D-274D-A784-FAA5CFF8E267}" type="datetimeFigureOut">
               <a:rPr lang="en-HU" smtClean="0"/>
-              <a:t>2025. 08. 13.</a:t>
+              <a:t>2025. 08. 27.</a:t>
             </a:fld>
             <a:endParaRPr lang="en-HU"/>
           </a:p>
@@ -1973,7 +1973,7 @@
           <a:p>
             <a:fld id="{2C01C9F1-F29D-274D-A784-FAA5CFF8E267}" type="datetimeFigureOut">
               <a:rPr lang="en-HU" smtClean="0"/>
-              <a:t>2025. 08. 13.</a:t>
+              <a:t>2025. 08. 27.</a:t>
             </a:fld>
             <a:endParaRPr lang="en-HU"/>
           </a:p>
@@ -2086,7 +2086,7 @@
           <a:p>
             <a:fld id="{2C01C9F1-F29D-274D-A784-FAA5CFF8E267}" type="datetimeFigureOut">
               <a:rPr lang="en-HU" smtClean="0"/>
-              <a:t>2025. 08. 12.</a:t>
+              <a:t>2025. 08. 27.</a:t>
             </a:fld>
             <a:endParaRPr lang="en-HU"/>
           </a:p>
@@ -2399,7 +2399,7 @@
           <a:p>
             <a:fld id="{2C01C9F1-F29D-274D-A784-FAA5CFF8E267}" type="datetimeFigureOut">
               <a:rPr lang="en-HU" smtClean="0"/>
-              <a:t>2025. 08. 13.</a:t>
+              <a:t>2025. 08. 27.</a:t>
             </a:fld>
             <a:endParaRPr lang="en-HU"/>
           </a:p>
@@ -2688,7 +2688,7 @@
           <a:p>
             <a:fld id="{2C01C9F1-F29D-274D-A784-FAA5CFF8E267}" type="datetimeFigureOut">
               <a:rPr lang="en-HU" smtClean="0"/>
-              <a:t>2025. 08. 13.</a:t>
+              <a:t>2025. 08. 27.</a:t>
             </a:fld>
             <a:endParaRPr lang="en-HU"/>
           </a:p>
@@ -2931,7 +2931,7 @@
           <a:p>
             <a:fld id="{2C01C9F1-F29D-274D-A784-FAA5CFF8E267}" type="datetimeFigureOut">
               <a:rPr lang="en-HU" smtClean="0"/>
-              <a:t>2025. 08. 12.</a:t>
+              <a:t>2025. 08. 27.</a:t>
             </a:fld>
             <a:endParaRPr lang="en-HU"/>
           </a:p>
@@ -4625,6 +4625,1344 @@
           <a:chExt cx="0" cy="0"/>
         </a:xfrm>
       </p:grpSpPr>
+      <p:sp>
+        <p:nvSpPr>
+          <p:cNvPr id="13" name="Rectangle 12">
+            <a:extLst>
+              <a:ext uri="{FF2B5EF4-FFF2-40B4-BE49-F238E27FC236}">
+                <a16:creationId xmlns:a16="http://schemas.microsoft.com/office/drawing/2014/main" id="{0068D7E6-6C7B-1A5B-FEF6-9D2181C00675}"/>
+              </a:ext>
+            </a:extLst>
+          </p:cNvPr>
+          <p:cNvSpPr/>
+          <p:nvPr/>
+        </p:nvSpPr>
+        <p:spPr>
+          <a:xfrm>
+            <a:off x="970157" y="797312"/>
+            <a:ext cx="1728439" cy="5263375"/>
+          </a:xfrm>
+          <a:prstGeom prst="rect">
+            <a:avLst/>
+          </a:prstGeom>
+        </p:spPr>
+        <p:style>
+          <a:lnRef idx="2">
+            <a:schemeClr val="accent1">
+              <a:shade val="15000"/>
+            </a:schemeClr>
+          </a:lnRef>
+          <a:fillRef idx="1">
+            <a:schemeClr val="accent1"/>
+          </a:fillRef>
+          <a:effectRef idx="0">
+            <a:schemeClr val="accent1"/>
+          </a:effectRef>
+          <a:fontRef idx="minor">
+            <a:schemeClr val="lt1"/>
+          </a:fontRef>
+        </p:style>
+        <p:txBody>
+          <a:bodyPr rtlCol="0" anchor="t"/>
+          <a:lstStyle/>
+          <a:p>
+            <a:pPr algn="ctr"/>
+            <a:r>
+              <a:rPr lang="en-HU" sz="1200" dirty="0"/>
+              <a:t>MiND</a:t>
+            </a:r>
+          </a:p>
+        </p:txBody>
+      </p:sp>
+      <p:sp>
+        <p:nvSpPr>
+          <p:cNvPr id="2" name="Rectangle 1">
+            <a:extLst>
+              <a:ext uri="{FF2B5EF4-FFF2-40B4-BE49-F238E27FC236}">
+                <a16:creationId xmlns:a16="http://schemas.microsoft.com/office/drawing/2014/main" id="{0EA710D2-58A5-92CE-DBA3-D5147C8A6E1A}"/>
+              </a:ext>
+            </a:extLst>
+          </p:cNvPr>
+          <p:cNvSpPr/>
+          <p:nvPr/>
+        </p:nvSpPr>
+        <p:spPr>
+          <a:xfrm>
+            <a:off x="4123083" y="797313"/>
+            <a:ext cx="1728439" cy="5263375"/>
+          </a:xfrm>
+          <a:prstGeom prst="rect">
+            <a:avLst/>
+          </a:prstGeom>
+        </p:spPr>
+        <p:style>
+          <a:lnRef idx="2">
+            <a:schemeClr val="accent1">
+              <a:shade val="15000"/>
+            </a:schemeClr>
+          </a:lnRef>
+          <a:fillRef idx="1">
+            <a:schemeClr val="accent1"/>
+          </a:fillRef>
+          <a:effectRef idx="0">
+            <a:schemeClr val="accent1"/>
+          </a:effectRef>
+          <a:fontRef idx="minor">
+            <a:schemeClr val="lt1"/>
+          </a:fontRef>
+        </p:style>
+        <p:txBody>
+          <a:bodyPr rtlCol="0" anchor="t"/>
+          <a:lstStyle/>
+          <a:p>
+            <a:pPr algn="ctr"/>
+            <a:r>
+              <a:rPr lang="en-HU" sz="1200" dirty="0"/>
+              <a:t>Dust</a:t>
+            </a:r>
+          </a:p>
+        </p:txBody>
+      </p:sp>
+      <p:sp>
+        <p:nvSpPr>
+          <p:cNvPr id="3" name="Rectangle 2">
+            <a:extLst>
+              <a:ext uri="{FF2B5EF4-FFF2-40B4-BE49-F238E27FC236}">
+                <a16:creationId xmlns:a16="http://schemas.microsoft.com/office/drawing/2014/main" id="{90546B79-CBA3-B7F0-00BB-F775C44D9E68}"/>
+              </a:ext>
+            </a:extLst>
+          </p:cNvPr>
+          <p:cNvSpPr/>
+          <p:nvPr/>
+        </p:nvSpPr>
+        <p:spPr>
+          <a:xfrm>
+            <a:off x="6653561" y="797312"/>
+            <a:ext cx="1728439" cy="5263375"/>
+          </a:xfrm>
+          <a:prstGeom prst="rect">
+            <a:avLst/>
+          </a:prstGeom>
+        </p:spPr>
+        <p:style>
+          <a:lnRef idx="2">
+            <a:schemeClr val="accent1">
+              <a:shade val="15000"/>
+            </a:schemeClr>
+          </a:lnRef>
+          <a:fillRef idx="1">
+            <a:schemeClr val="accent1"/>
+          </a:fillRef>
+          <a:effectRef idx="0">
+            <a:schemeClr val="accent1"/>
+          </a:effectRef>
+          <a:fontRef idx="minor">
+            <a:schemeClr val="lt1"/>
+          </a:fontRef>
+        </p:style>
+        <p:txBody>
+          <a:bodyPr rtlCol="0" anchor="t"/>
+          <a:lstStyle/>
+          <a:p>
+            <a:pPr algn="ctr"/>
+            <a:r>
+              <a:rPr lang="en-HU" sz="1200" dirty="0"/>
+              <a:t>DustJava</a:t>
+            </a:r>
+          </a:p>
+        </p:txBody>
+      </p:sp>
+      <p:sp>
+        <p:nvSpPr>
+          <p:cNvPr id="4" name="Rectangle 3">
+            <a:extLst>
+              <a:ext uri="{FF2B5EF4-FFF2-40B4-BE49-F238E27FC236}">
+                <a16:creationId xmlns:a16="http://schemas.microsoft.com/office/drawing/2014/main" id="{D5562221-BE26-C3ED-1D3D-F2D6FD2096C5}"/>
+              </a:ext>
+            </a:extLst>
+          </p:cNvPr>
+          <p:cNvSpPr/>
+          <p:nvPr/>
+        </p:nvSpPr>
+        <p:spPr>
+          <a:xfrm>
+            <a:off x="9575180" y="797312"/>
+            <a:ext cx="1728439" cy="5263375"/>
+          </a:xfrm>
+          <a:prstGeom prst="rect">
+            <a:avLst/>
+          </a:prstGeom>
+        </p:spPr>
+        <p:style>
+          <a:lnRef idx="2">
+            <a:schemeClr val="accent1">
+              <a:shade val="15000"/>
+            </a:schemeClr>
+          </a:lnRef>
+          <a:fillRef idx="1">
+            <a:schemeClr val="accent1"/>
+          </a:fillRef>
+          <a:effectRef idx="0">
+            <a:schemeClr val="accent1"/>
+          </a:effectRef>
+          <a:fontRef idx="minor">
+            <a:schemeClr val="lt1"/>
+          </a:fontRef>
+        </p:style>
+        <p:txBody>
+          <a:bodyPr rtlCol="0" anchor="t"/>
+          <a:lstStyle/>
+          <a:p>
+            <a:pPr algn="ctr"/>
+            <a:r>
+              <a:rPr lang="en-HU" sz="1200" dirty="0"/>
+              <a:t>Test01</a:t>
+            </a:r>
+          </a:p>
+          <a:p>
+            <a:pPr algn="ctr"/>
+            <a:r>
+              <a:rPr lang="en-HU" sz="1200" dirty="0"/>
+              <a:t>(monolithic)</a:t>
+            </a:r>
+          </a:p>
+        </p:txBody>
+      </p:sp>
+      <p:sp>
+        <p:nvSpPr>
+          <p:cNvPr id="5" name="Oval 4">
+            <a:extLst>
+              <a:ext uri="{FF2B5EF4-FFF2-40B4-BE49-F238E27FC236}">
+                <a16:creationId xmlns:a16="http://schemas.microsoft.com/office/drawing/2014/main" id="{EFD440DB-DD5E-AE43-D6D7-C155ABA60B61}"/>
+              </a:ext>
+            </a:extLst>
+          </p:cNvPr>
+          <p:cNvSpPr/>
+          <p:nvPr/>
+        </p:nvSpPr>
+        <p:spPr>
+          <a:xfrm>
+            <a:off x="9665399" y="1361209"/>
+            <a:ext cx="1548000" cy="288000"/>
+          </a:xfrm>
+          <a:prstGeom prst="ellipse">
+            <a:avLst/>
+          </a:prstGeom>
+        </p:spPr>
+        <p:style>
+          <a:lnRef idx="2">
+            <a:schemeClr val="accent3">
+              <a:shade val="15000"/>
+            </a:schemeClr>
+          </a:lnRef>
+          <a:fillRef idx="1">
+            <a:schemeClr val="accent3"/>
+          </a:fillRef>
+          <a:effectRef idx="0">
+            <a:schemeClr val="accent3"/>
+          </a:effectRef>
+          <a:fontRef idx="minor">
+            <a:schemeClr val="lt1"/>
+          </a:fontRef>
+        </p:style>
+        <p:txBody>
+          <a:bodyPr rtlCol="0" anchor="ctr"/>
+          <a:lstStyle/>
+          <a:p>
+            <a:pPr algn="ctr"/>
+            <a:r>
+              <a:rPr lang="en-HU" sz="1200" dirty="0"/>
+              <a:t>Machine</a:t>
+            </a:r>
+          </a:p>
+        </p:txBody>
+      </p:sp>
+      <p:sp>
+        <p:nvSpPr>
+          <p:cNvPr id="6" name="Rounded Rectangle 5">
+            <a:extLst>
+              <a:ext uri="{FF2B5EF4-FFF2-40B4-BE49-F238E27FC236}">
+                <a16:creationId xmlns:a16="http://schemas.microsoft.com/office/drawing/2014/main" id="{D1355493-DD87-AB24-BD68-FF020AE0804A}"/>
+              </a:ext>
+            </a:extLst>
+          </p:cNvPr>
+          <p:cNvSpPr/>
+          <p:nvPr/>
+        </p:nvSpPr>
+        <p:spPr>
+          <a:xfrm>
+            <a:off x="4213302" y="2458629"/>
+            <a:ext cx="1548000" cy="288000"/>
+          </a:xfrm>
+          <a:prstGeom prst="roundRect">
+            <a:avLst/>
+          </a:prstGeom>
+        </p:spPr>
+        <p:style>
+          <a:lnRef idx="2">
+            <a:schemeClr val="accent2">
+              <a:shade val="15000"/>
+            </a:schemeClr>
+          </a:lnRef>
+          <a:fillRef idx="1">
+            <a:schemeClr val="accent2"/>
+          </a:fillRef>
+          <a:effectRef idx="0">
+            <a:schemeClr val="accent2"/>
+          </a:effectRef>
+          <a:fontRef idx="minor">
+            <a:schemeClr val="lt1"/>
+          </a:fontRef>
+        </p:style>
+        <p:txBody>
+          <a:bodyPr rtlCol="0" anchor="ctr"/>
+          <a:lstStyle/>
+          <a:p>
+            <a:pPr algn="ctr"/>
+            <a:r>
+              <a:rPr lang="en-HU" sz="1200" dirty="0"/>
+              <a:t>{Modules}</a:t>
+            </a:r>
+          </a:p>
+        </p:txBody>
+      </p:sp>
+      <p:sp>
+        <p:nvSpPr>
+          <p:cNvPr id="7" name="Rounded Rectangle 6">
+            <a:extLst>
+              <a:ext uri="{FF2B5EF4-FFF2-40B4-BE49-F238E27FC236}">
+                <a16:creationId xmlns:a16="http://schemas.microsoft.com/office/drawing/2014/main" id="{6AC3AE67-C2AB-1D93-B5DA-71867E631A82}"/>
+              </a:ext>
+            </a:extLst>
+          </p:cNvPr>
+          <p:cNvSpPr/>
+          <p:nvPr/>
+        </p:nvSpPr>
+        <p:spPr>
+          <a:xfrm>
+            <a:off x="4213302" y="3187559"/>
+            <a:ext cx="1548000" cy="288000"/>
+          </a:xfrm>
+          <a:prstGeom prst="roundRect">
+            <a:avLst/>
+          </a:prstGeom>
+        </p:spPr>
+        <p:style>
+          <a:lnRef idx="2">
+            <a:schemeClr val="accent2">
+              <a:shade val="15000"/>
+            </a:schemeClr>
+          </a:lnRef>
+          <a:fillRef idx="1">
+            <a:schemeClr val="accent2"/>
+          </a:fillRef>
+          <a:effectRef idx="0">
+            <a:schemeClr val="accent2"/>
+          </a:effectRef>
+          <a:fontRef idx="minor">
+            <a:schemeClr val="lt1"/>
+          </a:fontRef>
+        </p:style>
+        <p:txBody>
+          <a:bodyPr rtlCol="0" anchor="ctr"/>
+          <a:lstStyle/>
+          <a:p>
+            <a:pPr algn="ctr"/>
+            <a:r>
+              <a:rPr lang="en-HU" sz="1200" dirty="0"/>
+              <a:t>{Logic-Binary}</a:t>
+            </a:r>
+          </a:p>
+        </p:txBody>
+      </p:sp>
+      <p:sp>
+        <p:nvSpPr>
+          <p:cNvPr id="8" name="Rounded Rectangle 7">
+            <a:extLst>
+              <a:ext uri="{FF2B5EF4-FFF2-40B4-BE49-F238E27FC236}">
+                <a16:creationId xmlns:a16="http://schemas.microsoft.com/office/drawing/2014/main" id="{6E2FEAB3-2ED6-8C26-7D95-F31DA25C039F}"/>
+              </a:ext>
+            </a:extLst>
+          </p:cNvPr>
+          <p:cNvSpPr/>
+          <p:nvPr/>
+        </p:nvSpPr>
+        <p:spPr>
+          <a:xfrm>
+            <a:off x="6743780" y="1696379"/>
+            <a:ext cx="1548000" cy="288000"/>
+          </a:xfrm>
+          <a:prstGeom prst="roundRect">
+            <a:avLst/>
+          </a:prstGeom>
+        </p:spPr>
+        <p:style>
+          <a:lnRef idx="2">
+            <a:schemeClr val="accent2">
+              <a:shade val="15000"/>
+            </a:schemeClr>
+          </a:lnRef>
+          <a:fillRef idx="1">
+            <a:schemeClr val="accent2"/>
+          </a:fillRef>
+          <a:effectRef idx="0">
+            <a:schemeClr val="accent2"/>
+          </a:effectRef>
+          <a:fontRef idx="minor">
+            <a:schemeClr val="lt1"/>
+          </a:fontRef>
+        </p:style>
+        <p:txBody>
+          <a:bodyPr rtlCol="0" anchor="ctr"/>
+          <a:lstStyle/>
+          <a:p>
+            <a:pPr algn="ctr"/>
+            <a:r>
+              <a:rPr lang="en-HU" sz="1200" dirty="0"/>
+              <a:t>{Logic-className}</a:t>
+            </a:r>
+          </a:p>
+        </p:txBody>
+      </p:sp>
+      <p:sp>
+        <p:nvSpPr>
+          <p:cNvPr id="9" name="Rounded Rectangle 8">
+            <a:extLst>
+              <a:ext uri="{FF2B5EF4-FFF2-40B4-BE49-F238E27FC236}">
+                <a16:creationId xmlns:a16="http://schemas.microsoft.com/office/drawing/2014/main" id="{66854B08-EE55-B15E-BC92-FB6CC16C4CEA}"/>
+              </a:ext>
+            </a:extLst>
+          </p:cNvPr>
+          <p:cNvSpPr/>
+          <p:nvPr/>
+        </p:nvSpPr>
+        <p:spPr>
+          <a:xfrm>
+            <a:off x="4213302" y="2104147"/>
+            <a:ext cx="1548000" cy="288000"/>
+          </a:xfrm>
+          <a:prstGeom prst="roundRect">
+            <a:avLst/>
+          </a:prstGeom>
+        </p:spPr>
+        <p:style>
+          <a:lnRef idx="2">
+            <a:schemeClr val="accent5">
+              <a:shade val="15000"/>
+            </a:schemeClr>
+          </a:lnRef>
+          <a:fillRef idx="1">
+            <a:schemeClr val="accent5"/>
+          </a:fillRef>
+          <a:effectRef idx="0">
+            <a:schemeClr val="accent5"/>
+          </a:effectRef>
+          <a:fontRef idx="minor">
+            <a:schemeClr val="lt1"/>
+          </a:fontRef>
+        </p:style>
+        <p:txBody>
+          <a:bodyPr rtlCol="0" anchor="ctr"/>
+          <a:lstStyle/>
+          <a:p>
+            <a:pPr algn="ctr"/>
+            <a:r>
+              <a:rPr lang="en-HU" sz="1200" dirty="0"/>
+              <a:t>Machine</a:t>
+            </a:r>
+          </a:p>
+        </p:txBody>
+      </p:sp>
+      <p:sp>
+        <p:nvSpPr>
+          <p:cNvPr id="10" name="Rounded Rectangle 9">
+            <a:extLst>
+              <a:ext uri="{FF2B5EF4-FFF2-40B4-BE49-F238E27FC236}">
+                <a16:creationId xmlns:a16="http://schemas.microsoft.com/office/drawing/2014/main" id="{4CBF307B-135E-B46E-6818-384F58B34BA1}"/>
+              </a:ext>
+            </a:extLst>
+          </p:cNvPr>
+          <p:cNvSpPr/>
+          <p:nvPr/>
+        </p:nvSpPr>
+        <p:spPr>
+          <a:xfrm>
+            <a:off x="4213302" y="3949300"/>
+            <a:ext cx="1548000" cy="288000"/>
+          </a:xfrm>
+          <a:prstGeom prst="roundRect">
+            <a:avLst/>
+          </a:prstGeom>
+        </p:spPr>
+        <p:style>
+          <a:lnRef idx="2">
+            <a:schemeClr val="accent5">
+              <a:shade val="15000"/>
+            </a:schemeClr>
+          </a:lnRef>
+          <a:fillRef idx="1">
+            <a:schemeClr val="accent5"/>
+          </a:fillRef>
+          <a:effectRef idx="0">
+            <a:schemeClr val="accent5"/>
+          </a:effectRef>
+          <a:fontRef idx="minor">
+            <a:schemeClr val="lt1"/>
+          </a:fontRef>
+        </p:style>
+        <p:txBody>
+          <a:bodyPr rtlCol="0" anchor="ctr"/>
+          <a:lstStyle/>
+          <a:p>
+            <a:pPr algn="ctr"/>
+            <a:r>
+              <a:rPr lang="en-HU" sz="1200" dirty="0"/>
+              <a:t>Module</a:t>
+            </a:r>
+          </a:p>
+        </p:txBody>
+      </p:sp>
+      <p:sp>
+        <p:nvSpPr>
+          <p:cNvPr id="11" name="Rounded Rectangle 10">
+            <a:extLst>
+              <a:ext uri="{FF2B5EF4-FFF2-40B4-BE49-F238E27FC236}">
+                <a16:creationId xmlns:a16="http://schemas.microsoft.com/office/drawing/2014/main" id="{D88CE76D-1614-5261-0478-39DB212141AC}"/>
+              </a:ext>
+            </a:extLst>
+          </p:cNvPr>
+          <p:cNvSpPr/>
+          <p:nvPr/>
+        </p:nvSpPr>
+        <p:spPr>
+          <a:xfrm>
+            <a:off x="1060376" y="4101982"/>
+            <a:ext cx="1548000" cy="288000"/>
+          </a:xfrm>
+          <a:prstGeom prst="roundRect">
+            <a:avLst/>
+          </a:prstGeom>
+        </p:spPr>
+        <p:style>
+          <a:lnRef idx="2">
+            <a:schemeClr val="accent5">
+              <a:shade val="15000"/>
+            </a:schemeClr>
+          </a:lnRef>
+          <a:fillRef idx="1">
+            <a:schemeClr val="accent5"/>
+          </a:fillRef>
+          <a:effectRef idx="0">
+            <a:schemeClr val="accent5"/>
+          </a:effectRef>
+          <a:fontRef idx="minor">
+            <a:schemeClr val="lt1"/>
+          </a:fontRef>
+        </p:style>
+        <p:txBody>
+          <a:bodyPr rtlCol="0" anchor="ctr"/>
+          <a:lstStyle/>
+          <a:p>
+            <a:pPr algn="ctr"/>
+            <a:r>
+              <a:rPr lang="en-HU" sz="1200" dirty="0"/>
+              <a:t>Logic</a:t>
+            </a:r>
+          </a:p>
+        </p:txBody>
+      </p:sp>
+      <p:sp>
+        <p:nvSpPr>
+          <p:cNvPr id="14" name="Rounded Rectangle 13">
+            <a:extLst>
+              <a:ext uri="{FF2B5EF4-FFF2-40B4-BE49-F238E27FC236}">
+                <a16:creationId xmlns:a16="http://schemas.microsoft.com/office/drawing/2014/main" id="{183BE596-E20D-4A41-2E99-6329206ECB4F}"/>
+              </a:ext>
+            </a:extLst>
+          </p:cNvPr>
+          <p:cNvSpPr/>
+          <p:nvPr/>
+        </p:nvSpPr>
+        <p:spPr>
+          <a:xfrm>
+            <a:off x="1060376" y="4636164"/>
+            <a:ext cx="1548000" cy="288000"/>
+          </a:xfrm>
+          <a:prstGeom prst="roundRect">
+            <a:avLst/>
+          </a:prstGeom>
+        </p:spPr>
+        <p:style>
+          <a:lnRef idx="2">
+            <a:schemeClr val="accent5">
+              <a:shade val="15000"/>
+            </a:schemeClr>
+          </a:lnRef>
+          <a:fillRef idx="1">
+            <a:schemeClr val="accent5"/>
+          </a:fillRef>
+          <a:effectRef idx="0">
+            <a:schemeClr val="accent5"/>
+          </a:effectRef>
+          <a:fontRef idx="minor">
+            <a:schemeClr val="lt1"/>
+          </a:fontRef>
+        </p:style>
+        <p:txBody>
+          <a:bodyPr rtlCol="0" anchor="ctr"/>
+          <a:lstStyle/>
+          <a:p>
+            <a:pPr algn="ctr"/>
+            <a:r>
+              <a:rPr lang="en-HU" sz="1200" dirty="0"/>
+              <a:t>Agent</a:t>
+            </a:r>
+          </a:p>
+        </p:txBody>
+      </p:sp>
+      <p:sp>
+        <p:nvSpPr>
+          <p:cNvPr id="15" name="Rounded Rectangle 14">
+            <a:extLst>
+              <a:ext uri="{FF2B5EF4-FFF2-40B4-BE49-F238E27FC236}">
+                <a16:creationId xmlns:a16="http://schemas.microsoft.com/office/drawing/2014/main" id="{6E532308-BF0E-12C0-A8D1-CC2DD1358CCA}"/>
+              </a:ext>
+            </a:extLst>
+          </p:cNvPr>
+          <p:cNvSpPr/>
+          <p:nvPr/>
+        </p:nvSpPr>
+        <p:spPr>
+          <a:xfrm>
+            <a:off x="1060376" y="4983105"/>
+            <a:ext cx="1548000" cy="288000"/>
+          </a:xfrm>
+          <a:prstGeom prst="roundRect">
+            <a:avLst/>
+          </a:prstGeom>
+        </p:spPr>
+        <p:style>
+          <a:lnRef idx="2">
+            <a:schemeClr val="accent2">
+              <a:shade val="15000"/>
+            </a:schemeClr>
+          </a:lnRef>
+          <a:fillRef idx="1">
+            <a:schemeClr val="accent2"/>
+          </a:fillRef>
+          <a:effectRef idx="0">
+            <a:schemeClr val="accent2"/>
+          </a:effectRef>
+          <a:fontRef idx="minor">
+            <a:schemeClr val="lt1"/>
+          </a:fontRef>
+        </p:style>
+        <p:txBody>
+          <a:bodyPr rtlCol="0" anchor="ctr"/>
+          <a:lstStyle/>
+          <a:p>
+            <a:pPr algn="ctr"/>
+            <a:r>
+              <a:rPr lang="en-HU" sz="1200" dirty="0"/>
+              <a:t>AgentLogic</a:t>
+            </a:r>
+          </a:p>
+        </p:txBody>
+      </p:sp>
+      <p:sp>
+        <p:nvSpPr>
+          <p:cNvPr id="16" name="Rounded Rectangle 15">
+            <a:extLst>
+              <a:ext uri="{FF2B5EF4-FFF2-40B4-BE49-F238E27FC236}">
+                <a16:creationId xmlns:a16="http://schemas.microsoft.com/office/drawing/2014/main" id="{6830E3AF-04F7-55E4-1B10-E7EADEBA4A87}"/>
+              </a:ext>
+            </a:extLst>
+          </p:cNvPr>
+          <p:cNvSpPr/>
+          <p:nvPr/>
+        </p:nvSpPr>
+        <p:spPr>
+          <a:xfrm>
+            <a:off x="1060376" y="2750828"/>
+            <a:ext cx="1548000" cy="288000"/>
+          </a:xfrm>
+          <a:prstGeom prst="roundRect">
+            <a:avLst/>
+          </a:prstGeom>
+        </p:spPr>
+        <p:style>
+          <a:lnRef idx="2">
+            <a:schemeClr val="accent5">
+              <a:shade val="15000"/>
+            </a:schemeClr>
+          </a:lnRef>
+          <a:fillRef idx="1">
+            <a:schemeClr val="accent5"/>
+          </a:fillRef>
+          <a:effectRef idx="0">
+            <a:schemeClr val="accent5"/>
+          </a:effectRef>
+          <a:fontRef idx="minor">
+            <a:schemeClr val="lt1"/>
+          </a:fontRef>
+        </p:style>
+        <p:txBody>
+          <a:bodyPr rtlCol="0" anchor="ctr"/>
+          <a:lstStyle/>
+          <a:p>
+            <a:pPr algn="ctr"/>
+            <a:r>
+              <a:rPr lang="en-HU" sz="1200" dirty="0"/>
+              <a:t>Dialog</a:t>
+            </a:r>
+          </a:p>
+        </p:txBody>
+      </p:sp>
+      <p:sp>
+        <p:nvSpPr>
+          <p:cNvPr id="17" name="Rounded Rectangle 16">
+            <a:extLst>
+              <a:ext uri="{FF2B5EF4-FFF2-40B4-BE49-F238E27FC236}">
+                <a16:creationId xmlns:a16="http://schemas.microsoft.com/office/drawing/2014/main" id="{7E9E5B0C-4832-8B09-6BA1-DB89CC627981}"/>
+              </a:ext>
+            </a:extLst>
+          </p:cNvPr>
+          <p:cNvSpPr/>
+          <p:nvPr/>
+        </p:nvSpPr>
+        <p:spPr>
+          <a:xfrm>
+            <a:off x="1060376" y="3105808"/>
+            <a:ext cx="1548000" cy="288000"/>
+          </a:xfrm>
+          <a:prstGeom prst="roundRect">
+            <a:avLst/>
+          </a:prstGeom>
+        </p:spPr>
+        <p:style>
+          <a:lnRef idx="2">
+            <a:schemeClr val="accent2">
+              <a:shade val="15000"/>
+            </a:schemeClr>
+          </a:lnRef>
+          <a:fillRef idx="1">
+            <a:schemeClr val="accent2"/>
+          </a:fillRef>
+          <a:effectRef idx="0">
+            <a:schemeClr val="accent2"/>
+          </a:effectRef>
+          <a:fontRef idx="minor">
+            <a:schemeClr val="lt1"/>
+          </a:fontRef>
+        </p:style>
+        <p:txBody>
+          <a:bodyPr rtlCol="0" anchor="ctr"/>
+          <a:lstStyle/>
+          <a:p>
+            <a:pPr algn="ctr"/>
+            <a:r>
+              <a:rPr lang="en-HU" sz="1200" dirty="0"/>
+              <a:t>{Ideas}</a:t>
+            </a:r>
+          </a:p>
+        </p:txBody>
+      </p:sp>
+      <p:sp>
+        <p:nvSpPr>
+          <p:cNvPr id="18" name="Rounded Rectangle 17">
+            <a:extLst>
+              <a:ext uri="{FF2B5EF4-FFF2-40B4-BE49-F238E27FC236}">
+                <a16:creationId xmlns:a16="http://schemas.microsoft.com/office/drawing/2014/main" id="{0534BD06-9F3B-82ED-2584-95F7109E9C18}"/>
+              </a:ext>
+            </a:extLst>
+          </p:cNvPr>
+          <p:cNvSpPr/>
+          <p:nvPr/>
+        </p:nvSpPr>
+        <p:spPr>
+          <a:xfrm>
+            <a:off x="1060376" y="1153684"/>
+            <a:ext cx="1548000" cy="288000"/>
+          </a:xfrm>
+          <a:prstGeom prst="roundRect">
+            <a:avLst/>
+          </a:prstGeom>
+        </p:spPr>
+        <p:style>
+          <a:lnRef idx="2">
+            <a:schemeClr val="accent5">
+              <a:shade val="15000"/>
+            </a:schemeClr>
+          </a:lnRef>
+          <a:fillRef idx="1">
+            <a:schemeClr val="accent5"/>
+          </a:fillRef>
+          <a:effectRef idx="0">
+            <a:schemeClr val="accent5"/>
+          </a:effectRef>
+          <a:fontRef idx="minor">
+            <a:schemeClr val="lt1"/>
+          </a:fontRef>
+        </p:style>
+        <p:txBody>
+          <a:bodyPr rtlCol="0" anchor="ctr"/>
+          <a:lstStyle/>
+          <a:p>
+            <a:pPr algn="ctr"/>
+            <a:r>
+              <a:rPr lang="en-HU" sz="1200" dirty="0"/>
+              <a:t>Idea</a:t>
+            </a:r>
+          </a:p>
+        </p:txBody>
+      </p:sp>
+      <p:sp>
+        <p:nvSpPr>
+          <p:cNvPr id="19" name="Rounded Rectangle 18">
+            <a:extLst>
+              <a:ext uri="{FF2B5EF4-FFF2-40B4-BE49-F238E27FC236}">
+                <a16:creationId xmlns:a16="http://schemas.microsoft.com/office/drawing/2014/main" id="{ADA3159F-7E6D-DD17-1306-2CDA1214997E}"/>
+              </a:ext>
+            </a:extLst>
+          </p:cNvPr>
+          <p:cNvSpPr/>
+          <p:nvPr/>
+        </p:nvSpPr>
+        <p:spPr>
+          <a:xfrm>
+            <a:off x="1060376" y="1508664"/>
+            <a:ext cx="1548000" cy="288000"/>
+          </a:xfrm>
+          <a:prstGeom prst="roundRect">
+            <a:avLst/>
+          </a:prstGeom>
+        </p:spPr>
+        <p:style>
+          <a:lnRef idx="2">
+            <a:schemeClr val="accent2">
+              <a:shade val="15000"/>
+            </a:schemeClr>
+          </a:lnRef>
+          <a:fillRef idx="1">
+            <a:schemeClr val="accent2"/>
+          </a:fillRef>
+          <a:effectRef idx="0">
+            <a:schemeClr val="accent2"/>
+          </a:effectRef>
+          <a:fontRef idx="minor">
+            <a:schemeClr val="lt1"/>
+          </a:fontRef>
+        </p:style>
+        <p:txBody>
+          <a:bodyPr rtlCol="0" anchor="ctr"/>
+          <a:lstStyle/>
+          <a:p>
+            <a:pPr algn="ctr"/>
+            <a:r>
+              <a:rPr lang="en-HU" sz="1200" dirty="0"/>
+              <a:t>Listeners</a:t>
+            </a:r>
+          </a:p>
+        </p:txBody>
+      </p:sp>
+      <p:sp>
+        <p:nvSpPr>
+          <p:cNvPr id="20" name="Rounded Rectangle 19">
+            <a:extLst>
+              <a:ext uri="{FF2B5EF4-FFF2-40B4-BE49-F238E27FC236}">
+                <a16:creationId xmlns:a16="http://schemas.microsoft.com/office/drawing/2014/main" id="{AAE355CB-E25F-329F-F2F2-DE85A621481D}"/>
+              </a:ext>
+            </a:extLst>
+          </p:cNvPr>
+          <p:cNvSpPr/>
+          <p:nvPr/>
+        </p:nvSpPr>
+        <p:spPr>
+          <a:xfrm>
+            <a:off x="1060376" y="3492888"/>
+            <a:ext cx="1548000" cy="288000"/>
+          </a:xfrm>
+          <a:prstGeom prst="roundRect">
+            <a:avLst/>
+          </a:prstGeom>
+        </p:spPr>
+        <p:style>
+          <a:lnRef idx="2">
+            <a:schemeClr val="accent2">
+              <a:shade val="15000"/>
+            </a:schemeClr>
+          </a:lnRef>
+          <a:fillRef idx="1">
+            <a:schemeClr val="accent2"/>
+          </a:fillRef>
+          <a:effectRef idx="0">
+            <a:schemeClr val="accent2"/>
+          </a:effectRef>
+          <a:fontRef idx="minor">
+            <a:schemeClr val="lt1"/>
+          </a:fontRef>
+        </p:style>
+        <p:txBody>
+          <a:bodyPr rtlCol="0" anchor="ctr"/>
+          <a:lstStyle/>
+          <a:p>
+            <a:pPr algn="ctr"/>
+            <a:r>
+              <a:rPr lang="en-HU" sz="1200" dirty="0"/>
+              <a:t>[InitIdeas]</a:t>
+            </a:r>
+          </a:p>
+        </p:txBody>
+      </p:sp>
+      <p:sp>
+        <p:nvSpPr>
+          <p:cNvPr id="21" name="Rounded Rectangle 20">
+            <a:extLst>
+              <a:ext uri="{FF2B5EF4-FFF2-40B4-BE49-F238E27FC236}">
+                <a16:creationId xmlns:a16="http://schemas.microsoft.com/office/drawing/2014/main" id="{FB4E5403-B1CA-7F99-7CF3-95577589211D}"/>
+              </a:ext>
+            </a:extLst>
+          </p:cNvPr>
+          <p:cNvSpPr/>
+          <p:nvPr/>
+        </p:nvSpPr>
+        <p:spPr>
+          <a:xfrm>
+            <a:off x="1060376" y="1880221"/>
+            <a:ext cx="1548000" cy="288000"/>
+          </a:xfrm>
+          <a:prstGeom prst="roundRect">
+            <a:avLst/>
+          </a:prstGeom>
+        </p:spPr>
+        <p:style>
+          <a:lnRef idx="2">
+            <a:schemeClr val="accent2">
+              <a:shade val="15000"/>
+            </a:schemeClr>
+          </a:lnRef>
+          <a:fillRef idx="1">
+            <a:schemeClr val="accent2"/>
+          </a:fillRef>
+          <a:effectRef idx="0">
+            <a:schemeClr val="accent2"/>
+          </a:effectRef>
+          <a:fontRef idx="minor">
+            <a:schemeClr val="lt1"/>
+          </a:fontRef>
+        </p:style>
+        <p:txBody>
+          <a:bodyPr rtlCol="0" anchor="ctr"/>
+          <a:lstStyle/>
+          <a:p>
+            <a:pPr algn="ctr"/>
+            <a:r>
+              <a:rPr lang="en-HU" sz="1200" dirty="0"/>
+              <a:t>Logic</a:t>
+            </a:r>
+          </a:p>
+        </p:txBody>
+      </p:sp>
+      <p:sp>
+        <p:nvSpPr>
+          <p:cNvPr id="22" name="Rounded Rectangle 21">
+            <a:extLst>
+              <a:ext uri="{FF2B5EF4-FFF2-40B4-BE49-F238E27FC236}">
+                <a16:creationId xmlns:a16="http://schemas.microsoft.com/office/drawing/2014/main" id="{0B734CF9-43BA-1CE2-F6D8-40477CE4D3ED}"/>
+              </a:ext>
+            </a:extLst>
+          </p:cNvPr>
+          <p:cNvSpPr/>
+          <p:nvPr/>
+        </p:nvSpPr>
+        <p:spPr>
+          <a:xfrm>
+            <a:off x="6743780" y="1312012"/>
+            <a:ext cx="1548000" cy="288000"/>
+          </a:xfrm>
+          <a:prstGeom prst="roundRect">
+            <a:avLst/>
+          </a:prstGeom>
+          <a:pattFill prst="lgCheck">
+            <a:fgClr>
+              <a:schemeClr val="accent5"/>
+            </a:fgClr>
+            <a:bgClr>
+              <a:schemeClr val="accent1"/>
+            </a:bgClr>
+          </a:pattFill>
+        </p:spPr>
+        <p:style>
+          <a:lnRef idx="2">
+            <a:schemeClr val="accent5">
+              <a:shade val="15000"/>
+            </a:schemeClr>
+          </a:lnRef>
+          <a:fillRef idx="1">
+            <a:schemeClr val="accent5"/>
+          </a:fillRef>
+          <a:effectRef idx="0">
+            <a:schemeClr val="accent5"/>
+          </a:effectRef>
+          <a:fontRef idx="minor">
+            <a:schemeClr val="lt1"/>
+          </a:fontRef>
+        </p:style>
+        <p:txBody>
+          <a:bodyPr rtlCol="0" anchor="ctr"/>
+          <a:lstStyle/>
+          <a:p>
+            <a:pPr algn="ctr"/>
+            <a:r>
+              <a:rPr lang="en-HU" sz="1200" dirty="0"/>
+              <a:t>Module</a:t>
+            </a:r>
+          </a:p>
+        </p:txBody>
+      </p:sp>
+      <p:sp>
+        <p:nvSpPr>
+          <p:cNvPr id="23" name="Rounded Rectangle 22">
+            <a:extLst>
+              <a:ext uri="{FF2B5EF4-FFF2-40B4-BE49-F238E27FC236}">
+                <a16:creationId xmlns:a16="http://schemas.microsoft.com/office/drawing/2014/main" id="{B1819576-7CA3-E9A1-C0AC-B5F83A035F67}"/>
+              </a:ext>
+            </a:extLst>
+          </p:cNvPr>
+          <p:cNvSpPr/>
+          <p:nvPr/>
+        </p:nvSpPr>
+        <p:spPr>
+          <a:xfrm>
+            <a:off x="4213302" y="4493810"/>
+            <a:ext cx="1548000" cy="288000"/>
+          </a:xfrm>
+          <a:prstGeom prst="roundRect">
+            <a:avLst/>
+          </a:prstGeom>
+        </p:spPr>
+        <p:style>
+          <a:lnRef idx="2">
+            <a:schemeClr val="accent5">
+              <a:shade val="15000"/>
+            </a:schemeClr>
+          </a:lnRef>
+          <a:fillRef idx="1">
+            <a:schemeClr val="accent5"/>
+          </a:fillRef>
+          <a:effectRef idx="0">
+            <a:schemeClr val="accent5"/>
+          </a:effectRef>
+          <a:fontRef idx="minor">
+            <a:schemeClr val="lt1"/>
+          </a:fontRef>
+        </p:style>
+        <p:txBody>
+          <a:bodyPr rtlCol="0" anchor="ctr"/>
+          <a:lstStyle/>
+          <a:p>
+            <a:pPr algn="ctr"/>
+            <a:r>
+              <a:rPr lang="en-HU" sz="1200" dirty="0"/>
+              <a:t>UnitLoader</a:t>
+            </a:r>
+          </a:p>
+        </p:txBody>
+      </p:sp>
+      <p:sp>
+        <p:nvSpPr>
+          <p:cNvPr id="24" name="Rounded Rectangle 23">
+            <a:extLst>
+              <a:ext uri="{FF2B5EF4-FFF2-40B4-BE49-F238E27FC236}">
+                <a16:creationId xmlns:a16="http://schemas.microsoft.com/office/drawing/2014/main" id="{3B7920F8-7F27-9A8A-F501-12F7D5383886}"/>
+              </a:ext>
+            </a:extLst>
+          </p:cNvPr>
+          <p:cNvSpPr/>
+          <p:nvPr/>
+        </p:nvSpPr>
+        <p:spPr>
+          <a:xfrm>
+            <a:off x="6743780" y="2114712"/>
+            <a:ext cx="1548000" cy="288000"/>
+          </a:xfrm>
+          <a:prstGeom prst="roundRect">
+            <a:avLst/>
+          </a:prstGeom>
+        </p:spPr>
+        <p:style>
+          <a:lnRef idx="2">
+            <a:schemeClr val="accent2">
+              <a:shade val="15000"/>
+            </a:schemeClr>
+          </a:lnRef>
+          <a:fillRef idx="1">
+            <a:schemeClr val="accent2"/>
+          </a:fillRef>
+          <a:effectRef idx="0">
+            <a:schemeClr val="accent2"/>
+          </a:effectRef>
+          <a:fontRef idx="minor">
+            <a:schemeClr val="lt1"/>
+          </a:fontRef>
+        </p:style>
+        <p:txBody>
+          <a:bodyPr rtlCol="0" anchor="ctr"/>
+          <a:lstStyle/>
+          <a:p>
+            <a:pPr algn="ctr"/>
+            <a:r>
+              <a:rPr lang="en-HU" sz="1200" dirty="0"/>
+              <a:t>Classloader</a:t>
+            </a:r>
+          </a:p>
+        </p:txBody>
+      </p:sp>
+      <p:sp>
+        <p:nvSpPr>
+          <p:cNvPr id="25" name="Oval 24">
+            <a:extLst>
+              <a:ext uri="{FF2B5EF4-FFF2-40B4-BE49-F238E27FC236}">
+                <a16:creationId xmlns:a16="http://schemas.microsoft.com/office/drawing/2014/main" id="{C6A989A5-327E-40F4-291D-775A60E6855D}"/>
+              </a:ext>
+            </a:extLst>
+          </p:cNvPr>
+          <p:cNvSpPr/>
+          <p:nvPr/>
+        </p:nvSpPr>
+        <p:spPr>
+          <a:xfrm>
+            <a:off x="9665399" y="2268611"/>
+            <a:ext cx="1638220" cy="288001"/>
+          </a:xfrm>
+          <a:prstGeom prst="ellipse">
+            <a:avLst/>
+          </a:prstGeom>
+        </p:spPr>
+        <p:style>
+          <a:lnRef idx="2">
+            <a:schemeClr val="accent3">
+              <a:shade val="15000"/>
+            </a:schemeClr>
+          </a:lnRef>
+          <a:fillRef idx="1">
+            <a:schemeClr val="accent3"/>
+          </a:fillRef>
+          <a:effectRef idx="0">
+            <a:schemeClr val="accent3"/>
+          </a:effectRef>
+          <a:fontRef idx="minor">
+            <a:schemeClr val="lt1"/>
+          </a:fontRef>
+        </p:style>
+        <p:txBody>
+          <a:bodyPr rtlCol="0" anchor="ctr"/>
+          <a:lstStyle/>
+          <a:p>
+            <a:pPr algn="ctr"/>
+            <a:r>
+              <a:rPr lang="en-HU" sz="1200" dirty="0"/>
+              <a:t>BinaryCreator</a:t>
+            </a:r>
+          </a:p>
+        </p:txBody>
+      </p:sp>
+      <p:sp>
+        <p:nvSpPr>
+          <p:cNvPr id="26" name="Oval 25">
+            <a:extLst>
+              <a:ext uri="{FF2B5EF4-FFF2-40B4-BE49-F238E27FC236}">
+                <a16:creationId xmlns:a16="http://schemas.microsoft.com/office/drawing/2014/main" id="{F797176A-9048-AC2E-2A4B-2964CAD2CCBD}"/>
+              </a:ext>
+            </a:extLst>
+          </p:cNvPr>
+          <p:cNvSpPr/>
+          <p:nvPr/>
+        </p:nvSpPr>
+        <p:spPr>
+          <a:xfrm>
+            <a:off x="9673843" y="1770532"/>
+            <a:ext cx="1548000" cy="288000"/>
+          </a:xfrm>
+          <a:prstGeom prst="ellipse">
+            <a:avLst/>
+          </a:prstGeom>
+        </p:spPr>
+        <p:style>
+          <a:lnRef idx="2">
+            <a:schemeClr val="accent3">
+              <a:shade val="15000"/>
+            </a:schemeClr>
+          </a:lnRef>
+          <a:fillRef idx="1">
+            <a:schemeClr val="accent3"/>
+          </a:fillRef>
+          <a:effectRef idx="0">
+            <a:schemeClr val="accent3"/>
+          </a:effectRef>
+          <a:fontRef idx="minor">
+            <a:schemeClr val="lt1"/>
+          </a:fontRef>
+        </p:style>
+        <p:txBody>
+          <a:bodyPr rtlCol="0" anchor="ctr"/>
+          <a:lstStyle/>
+          <a:p>
+            <a:pPr algn="ctr"/>
+            <a:r>
+              <a:rPr lang="en-HU" sz="1200" dirty="0"/>
+              <a:t>TestModule</a:t>
+            </a:r>
+          </a:p>
+        </p:txBody>
+      </p:sp>
+      <p:sp>
+        <p:nvSpPr>
+          <p:cNvPr id="27" name="Rounded Rectangle 26">
+            <a:extLst>
+              <a:ext uri="{FF2B5EF4-FFF2-40B4-BE49-F238E27FC236}">
+                <a16:creationId xmlns:a16="http://schemas.microsoft.com/office/drawing/2014/main" id="{96ADEB0D-68C3-E811-EFA1-ECC0387A6B77}"/>
+              </a:ext>
+            </a:extLst>
+          </p:cNvPr>
+          <p:cNvSpPr/>
+          <p:nvPr/>
+        </p:nvSpPr>
+        <p:spPr>
+          <a:xfrm>
+            <a:off x="4213302" y="2823094"/>
+            <a:ext cx="1548000" cy="288000"/>
+          </a:xfrm>
+          <a:prstGeom prst="roundRect">
+            <a:avLst/>
+          </a:prstGeom>
+        </p:spPr>
+        <p:style>
+          <a:lnRef idx="2">
+            <a:schemeClr val="accent2">
+              <a:shade val="15000"/>
+            </a:schemeClr>
+          </a:lnRef>
+          <a:fillRef idx="1">
+            <a:schemeClr val="accent2"/>
+          </a:fillRef>
+          <a:effectRef idx="0">
+            <a:schemeClr val="accent2"/>
+          </a:effectRef>
+          <a:fontRef idx="minor">
+            <a:schemeClr val="lt1"/>
+          </a:fontRef>
+        </p:style>
+        <p:txBody>
+          <a:bodyPr rtlCol="0" anchor="ctr"/>
+          <a:lstStyle/>
+          <a:p>
+            <a:pPr algn="ctr"/>
+            <a:r>
+              <a:rPr lang="en-HU" sz="1200" dirty="0"/>
+              <a:t>UnitLoader</a:t>
+            </a:r>
+          </a:p>
+        </p:txBody>
+      </p:sp>
+      <p:sp>
+        <p:nvSpPr>
+          <p:cNvPr id="12" name="Rounded Rectangle 11">
+            <a:extLst>
+              <a:ext uri="{FF2B5EF4-FFF2-40B4-BE49-F238E27FC236}">
+                <a16:creationId xmlns:a16="http://schemas.microsoft.com/office/drawing/2014/main" id="{46DE2CBF-8FED-A218-5377-D7050DD8A491}"/>
+              </a:ext>
+            </a:extLst>
+          </p:cNvPr>
+          <p:cNvSpPr/>
+          <p:nvPr/>
+        </p:nvSpPr>
+        <p:spPr>
+          <a:xfrm>
+            <a:off x="6743780" y="2698431"/>
+            <a:ext cx="1548000" cy="288000"/>
+          </a:xfrm>
+          <a:prstGeom prst="roundRect">
+            <a:avLst/>
+          </a:prstGeom>
+        </p:spPr>
+        <p:style>
+          <a:lnRef idx="2">
+            <a:schemeClr val="accent5">
+              <a:shade val="15000"/>
+            </a:schemeClr>
+          </a:lnRef>
+          <a:fillRef idx="1">
+            <a:schemeClr val="accent5"/>
+          </a:fillRef>
+          <a:effectRef idx="0">
+            <a:schemeClr val="accent5"/>
+          </a:effectRef>
+          <a:fontRef idx="minor">
+            <a:schemeClr val="lt1"/>
+          </a:fontRef>
+        </p:style>
+        <p:txBody>
+          <a:bodyPr rtlCol="0" anchor="ctr"/>
+          <a:lstStyle/>
+          <a:p>
+            <a:pPr algn="ctr"/>
+            <a:r>
+              <a:rPr lang="en-HU" sz="1200" dirty="0"/>
+              <a:t>BinaryCreator</a:t>
+            </a:r>
+          </a:p>
+        </p:txBody>
+      </p:sp>
+      <p:sp>
+        <p:nvSpPr>
+          <p:cNvPr id="28" name="Oval 27">
+            <a:extLst>
+              <a:ext uri="{FF2B5EF4-FFF2-40B4-BE49-F238E27FC236}">
+                <a16:creationId xmlns:a16="http://schemas.microsoft.com/office/drawing/2014/main" id="{8538175A-5C2D-95DC-4E6A-3F7EDE8C0C8C}"/>
+              </a:ext>
+            </a:extLst>
+          </p:cNvPr>
+          <p:cNvSpPr/>
+          <p:nvPr/>
+        </p:nvSpPr>
+        <p:spPr>
+          <a:xfrm>
+            <a:off x="9628733" y="2725398"/>
+            <a:ext cx="1638220" cy="288001"/>
+          </a:xfrm>
+          <a:prstGeom prst="ellipse">
+            <a:avLst/>
+          </a:prstGeom>
+        </p:spPr>
+        <p:style>
+          <a:lnRef idx="2">
+            <a:schemeClr val="accent3">
+              <a:shade val="15000"/>
+            </a:schemeClr>
+          </a:lnRef>
+          <a:fillRef idx="1">
+            <a:schemeClr val="accent3"/>
+          </a:fillRef>
+          <a:effectRef idx="0">
+            <a:schemeClr val="accent3"/>
+          </a:effectRef>
+          <a:fontRef idx="minor">
+            <a:schemeClr val="lt1"/>
+          </a:fontRef>
+        </p:style>
+        <p:txBody>
+          <a:bodyPr rtlCol="0" anchor="ctr"/>
+          <a:lstStyle/>
+          <a:p>
+            <a:pPr algn="ctr"/>
+            <a:r>
+              <a:rPr lang="en-HU" sz="1200" dirty="0"/>
+              <a:t>UnitLoader</a:t>
+            </a:r>
+          </a:p>
+        </p:txBody>
+      </p:sp>
     </p:spTree>
     <p:extLst>
       <p:ext uri="{BB962C8B-B14F-4D97-AF65-F5344CB8AC3E}">

</xml_diff>

<commit_message>
G06 - QnD changes for walking the machine unit list
</commit_message>
<xml_diff>
--- a/Generations/G06/doc/G06_slides.pptx
+++ b/Generations/G06/doc/G06_slides.pptx
@@ -7,6 +7,7 @@
   <p:sldIdLst>
     <p:sldId id="256" r:id="rId2"/>
     <p:sldId id="257" r:id="rId3"/>
+    <p:sldId id="258" r:id="rId4"/>
   </p:sldIdLst>
   <p:sldSz cx="12192000" cy="6858000"/>
   <p:notesSz cx="6858000" cy="9144000"/>
@@ -262,7 +263,7 @@
           <a:p>
             <a:fld id="{2C01C9F1-F29D-274D-A784-FAA5CFF8E267}" type="datetimeFigureOut">
               <a:rPr lang="en-HU" smtClean="0"/>
-              <a:t>2025. 08. 27.</a:t>
+              <a:t>2025. 09. 22.</a:t>
             </a:fld>
             <a:endParaRPr lang="en-HU"/>
           </a:p>
@@ -462,7 +463,7 @@
           <a:p>
             <a:fld id="{2C01C9F1-F29D-274D-A784-FAA5CFF8E267}" type="datetimeFigureOut">
               <a:rPr lang="en-HU" smtClean="0"/>
-              <a:t>2025. 08. 27.</a:t>
+              <a:t>2025. 09. 22.</a:t>
             </a:fld>
             <a:endParaRPr lang="en-HU"/>
           </a:p>
@@ -672,7 +673,7 @@
           <a:p>
             <a:fld id="{2C01C9F1-F29D-274D-A784-FAA5CFF8E267}" type="datetimeFigureOut">
               <a:rPr lang="en-HU" smtClean="0"/>
-              <a:t>2025. 08. 27.</a:t>
+              <a:t>2025. 09. 22.</a:t>
             </a:fld>
             <a:endParaRPr lang="en-HU"/>
           </a:p>
@@ -872,7 +873,7 @@
           <a:p>
             <a:fld id="{2C01C9F1-F29D-274D-A784-FAA5CFF8E267}" type="datetimeFigureOut">
               <a:rPr lang="en-HU" smtClean="0"/>
-              <a:t>2025. 08. 27.</a:t>
+              <a:t>2025. 09. 22.</a:t>
             </a:fld>
             <a:endParaRPr lang="en-HU"/>
           </a:p>
@@ -1148,7 +1149,7 @@
           <a:p>
             <a:fld id="{2C01C9F1-F29D-274D-A784-FAA5CFF8E267}" type="datetimeFigureOut">
               <a:rPr lang="en-HU" smtClean="0"/>
-              <a:t>2025. 08. 27.</a:t>
+              <a:t>2025. 09. 22.</a:t>
             </a:fld>
             <a:endParaRPr lang="en-HU"/>
           </a:p>
@@ -1416,7 +1417,7 @@
           <a:p>
             <a:fld id="{2C01C9F1-F29D-274D-A784-FAA5CFF8E267}" type="datetimeFigureOut">
               <a:rPr lang="en-HU" smtClean="0"/>
-              <a:t>2025. 08. 27.</a:t>
+              <a:t>2025. 09. 22.</a:t>
             </a:fld>
             <a:endParaRPr lang="en-HU"/>
           </a:p>
@@ -1831,7 +1832,7 @@
           <a:p>
             <a:fld id="{2C01C9F1-F29D-274D-A784-FAA5CFF8E267}" type="datetimeFigureOut">
               <a:rPr lang="en-HU" smtClean="0"/>
-              <a:t>2025. 08. 27.</a:t>
+              <a:t>2025. 09. 22.</a:t>
             </a:fld>
             <a:endParaRPr lang="en-HU"/>
           </a:p>
@@ -1973,7 +1974,7 @@
           <a:p>
             <a:fld id="{2C01C9F1-F29D-274D-A784-FAA5CFF8E267}" type="datetimeFigureOut">
               <a:rPr lang="en-HU" smtClean="0"/>
-              <a:t>2025. 08. 27.</a:t>
+              <a:t>2025. 09. 22.</a:t>
             </a:fld>
             <a:endParaRPr lang="en-HU"/>
           </a:p>
@@ -2086,7 +2087,7 @@
           <a:p>
             <a:fld id="{2C01C9F1-F29D-274D-A784-FAA5CFF8E267}" type="datetimeFigureOut">
               <a:rPr lang="en-HU" smtClean="0"/>
-              <a:t>2025. 08. 27.</a:t>
+              <a:t>2025. 09. 22.</a:t>
             </a:fld>
             <a:endParaRPr lang="en-HU"/>
           </a:p>
@@ -2399,7 +2400,7 @@
           <a:p>
             <a:fld id="{2C01C9F1-F29D-274D-A784-FAA5CFF8E267}" type="datetimeFigureOut">
               <a:rPr lang="en-HU" smtClean="0"/>
-              <a:t>2025. 08. 27.</a:t>
+              <a:t>2025. 09. 22.</a:t>
             </a:fld>
             <a:endParaRPr lang="en-HU"/>
           </a:p>
@@ -2688,7 +2689,7 @@
           <a:p>
             <a:fld id="{2C01C9F1-F29D-274D-A784-FAA5CFF8E267}" type="datetimeFigureOut">
               <a:rPr lang="en-HU" smtClean="0"/>
-              <a:t>2025. 08. 27.</a:t>
+              <a:t>2025. 09. 22.</a:t>
             </a:fld>
             <a:endParaRPr lang="en-HU"/>
           </a:p>
@@ -2931,7 +2932,7 @@
           <a:p>
             <a:fld id="{2C01C9F1-F29D-274D-A784-FAA5CFF8E267}" type="datetimeFigureOut">
               <a:rPr lang="en-HU" smtClean="0"/>
-              <a:t>2025. 08. 27.</a:t>
+              <a:t>2025. 09. 22.</a:t>
             </a:fld>
             <a:endParaRPr lang="en-HU"/>
           </a:p>
@@ -5967,6 +5968,397 @@
     <p:extLst>
       <p:ext uri="{BB962C8B-B14F-4D97-AF65-F5344CB8AC3E}">
         <p14:creationId xmlns:p14="http://schemas.microsoft.com/office/powerpoint/2010/main" val="1143076194"/>
+      </p:ext>
+    </p:extLst>
+  </p:cSld>
+  <p:clrMapOvr>
+    <a:masterClrMapping/>
+  </p:clrMapOvr>
+</p:sld>
+</file>
+
+<file path=ppt/slides/slide3.xml><?xml version="1.0" encoding="utf-8"?>
+<p:sld xmlns:a="http://schemas.openxmlformats.org/drawingml/2006/main" xmlns:r="http://schemas.openxmlformats.org/officeDocument/2006/relationships" xmlns:p="http://schemas.openxmlformats.org/presentationml/2006/main">
+  <p:cSld>
+    <p:spTree>
+      <p:nvGrpSpPr>
+        <p:cNvPr id="1" name=""/>
+        <p:cNvGrpSpPr/>
+        <p:nvPr/>
+      </p:nvGrpSpPr>
+      <p:grpSpPr>
+        <a:xfrm>
+          <a:off x="0" y="0"/>
+          <a:ext cx="0" cy="0"/>
+          <a:chOff x="0" y="0"/>
+          <a:chExt cx="0" cy="0"/>
+        </a:xfrm>
+      </p:grpSpPr>
+      <p:sp>
+        <p:nvSpPr>
+          <p:cNvPr id="2" name="Plaque 1">
+            <a:extLst>
+              <a:ext uri="{FF2B5EF4-FFF2-40B4-BE49-F238E27FC236}">
+                <a16:creationId xmlns:a16="http://schemas.microsoft.com/office/drawing/2014/main" id="{6430AA55-4F3C-2ED6-5D1C-25626CDAB434}"/>
+              </a:ext>
+            </a:extLst>
+          </p:cNvPr>
+          <p:cNvSpPr/>
+          <p:nvPr/>
+        </p:nvSpPr>
+        <p:spPr>
+          <a:xfrm>
+            <a:off x="546137" y="437877"/>
+            <a:ext cx="1259515" cy="388957"/>
+          </a:xfrm>
+          <a:prstGeom prst="plaque">
+            <a:avLst/>
+          </a:prstGeom>
+        </p:spPr>
+        <p:style>
+          <a:lnRef idx="2">
+            <a:schemeClr val="accent6"/>
+          </a:lnRef>
+          <a:fillRef idx="1">
+            <a:schemeClr val="lt1"/>
+          </a:fillRef>
+          <a:effectRef idx="0">
+            <a:schemeClr val="accent6"/>
+          </a:effectRef>
+          <a:fontRef idx="minor">
+            <a:schemeClr val="dk1"/>
+          </a:fontRef>
+        </p:style>
+        <p:txBody>
+          <a:bodyPr rtlCol="0" anchor="t" anchorCtr="0"/>
+          <a:lstStyle/>
+          <a:p>
+            <a:pPr algn="ctr"/>
+            <a:r>
+              <a:rPr lang="en-HU" sz="1200" dirty="0"/>
+              <a:t>MachineLogic</a:t>
+            </a:r>
+          </a:p>
+        </p:txBody>
+      </p:sp>
+      <p:sp>
+        <p:nvSpPr>
+          <p:cNvPr id="3" name="Snip Single Corner of Rectangle 2">
+            <a:extLst>
+              <a:ext uri="{FF2B5EF4-FFF2-40B4-BE49-F238E27FC236}">
+                <a16:creationId xmlns:a16="http://schemas.microsoft.com/office/drawing/2014/main" id="{7270939A-3972-7BC3-2715-DE3068C0A18E}"/>
+              </a:ext>
+            </a:extLst>
+          </p:cNvPr>
+          <p:cNvSpPr/>
+          <p:nvPr/>
+        </p:nvSpPr>
+        <p:spPr>
+          <a:xfrm>
+            <a:off x="962744" y="1798329"/>
+            <a:ext cx="2636983" cy="1918329"/>
+          </a:xfrm>
+          <a:prstGeom prst="snip1Rect">
+            <a:avLst/>
+          </a:prstGeom>
+        </p:spPr>
+        <p:style>
+          <a:lnRef idx="2">
+            <a:schemeClr val="accent6"/>
+          </a:lnRef>
+          <a:fillRef idx="1">
+            <a:schemeClr val="lt1"/>
+          </a:fillRef>
+          <a:effectRef idx="0">
+            <a:schemeClr val="accent6"/>
+          </a:effectRef>
+          <a:fontRef idx="minor">
+            <a:schemeClr val="dk1"/>
+          </a:fontRef>
+        </p:style>
+        <p:txBody>
+          <a:bodyPr rtlCol="0" anchor="t"/>
+          <a:lstStyle/>
+          <a:p>
+            <a:r>
+              <a:rPr lang="en-HU" sz="1200" dirty="0"/>
+              <a:t>MachineIdea (Unit)</a:t>
+            </a:r>
+          </a:p>
+          <a:p>
+            <a:pPr marL="171450" indent="-171450">
+              <a:buFont typeface="Arial" panose="020B0604020202020204" pitchFamily="34" charset="0"/>
+              <a:buChar char="•"/>
+            </a:pPr>
+            <a:r>
+              <a:rPr lang="en-HU" sz="1200" dirty="0"/>
+              <a:t>Logic (Machine)</a:t>
+            </a:r>
+          </a:p>
+          <a:p>
+            <a:pPr marL="171450" indent="-171450">
+              <a:buFont typeface="Arial" panose="020B0604020202020204" pitchFamily="34" charset="0"/>
+              <a:buChar char="•"/>
+            </a:pPr>
+            <a:r>
+              <a:rPr lang="en-HU" sz="1200" dirty="0"/>
+              <a:t>MachineDialogs</a:t>
+            </a:r>
+          </a:p>
+          <a:p>
+            <a:pPr marL="171450" indent="-171450">
+              <a:buFont typeface="Arial" panose="020B0604020202020204" pitchFamily="34" charset="0"/>
+              <a:buChar char="•"/>
+            </a:pPr>
+            <a:r>
+              <a:rPr lang="en-HU" sz="1200" dirty="0"/>
+              <a:t>MachineThreads</a:t>
+            </a:r>
+          </a:p>
+          <a:p>
+            <a:pPr marL="171450" indent="-171450">
+              <a:buFont typeface="Arial" panose="020B0604020202020204" pitchFamily="34" charset="0"/>
+              <a:buChar char="•"/>
+            </a:pPr>
+            <a:r>
+              <a:rPr lang="en-HU" sz="1200" dirty="0"/>
+              <a:t>MachineModules</a:t>
+            </a:r>
+          </a:p>
+          <a:p>
+            <a:pPr marL="171450" indent="-171450">
+              <a:buFont typeface="Arial" panose="020B0604020202020204" pitchFamily="34" charset="0"/>
+              <a:buChar char="•"/>
+            </a:pPr>
+            <a:r>
+              <a:rPr lang="en-HU" sz="1200" dirty="0"/>
+              <a:t>MachineUnits (incl Modules)</a:t>
+            </a:r>
+          </a:p>
+          <a:p>
+            <a:pPr marL="171450" indent="-171450">
+              <a:buFont typeface="Arial" panose="020B0604020202020204" pitchFamily="34" charset="0"/>
+              <a:buChar char="•"/>
+            </a:pPr>
+            <a:r>
+              <a:rPr lang="en-HU" sz="1200" dirty="0"/>
+              <a:t>UnitHandles (ID-handle map)</a:t>
+            </a:r>
+          </a:p>
+          <a:p>
+            <a:pPr marL="171450" indent="-171450">
+              <a:buFont typeface="Arial" panose="020B0604020202020204" pitchFamily="34" charset="0"/>
+              <a:buChar char="•"/>
+            </a:pPr>
+            <a:r>
+              <a:rPr lang="en-HU" sz="1200" dirty="0"/>
+              <a:t>UnitIdeas (handle-idea map)</a:t>
+            </a:r>
+          </a:p>
+        </p:txBody>
+      </p:sp>
+      <p:sp>
+        <p:nvSpPr>
+          <p:cNvPr id="4" name="Snip Single Corner of Rectangle 3">
+            <a:extLst>
+              <a:ext uri="{FF2B5EF4-FFF2-40B4-BE49-F238E27FC236}">
+                <a16:creationId xmlns:a16="http://schemas.microsoft.com/office/drawing/2014/main" id="{453C8764-7505-9791-9829-969B845CC94F}"/>
+              </a:ext>
+            </a:extLst>
+          </p:cNvPr>
+          <p:cNvSpPr/>
+          <p:nvPr/>
+        </p:nvSpPr>
+        <p:spPr>
+          <a:xfrm>
+            <a:off x="4749595" y="2547174"/>
+            <a:ext cx="1477389" cy="1165973"/>
+          </a:xfrm>
+          <a:prstGeom prst="snip1Rect">
+            <a:avLst/>
+          </a:prstGeom>
+        </p:spPr>
+        <p:style>
+          <a:lnRef idx="2">
+            <a:schemeClr val="accent6"/>
+          </a:lnRef>
+          <a:fillRef idx="1">
+            <a:schemeClr val="lt1"/>
+          </a:fillRef>
+          <a:effectRef idx="0">
+            <a:schemeClr val="accent6"/>
+          </a:effectRef>
+          <a:fontRef idx="minor">
+            <a:schemeClr val="dk1"/>
+          </a:fontRef>
+        </p:style>
+        <p:txBody>
+          <a:bodyPr rtlCol="0" anchor="t"/>
+          <a:lstStyle/>
+          <a:p>
+            <a:r>
+              <a:rPr lang="en-HU" sz="1200" dirty="0"/>
+              <a:t>ThreadIdea</a:t>
+            </a:r>
+          </a:p>
+          <a:p>
+            <a:pPr marL="171450" indent="-171450">
+              <a:buFont typeface="Arial" panose="020B0604020202020204" pitchFamily="34" charset="0"/>
+              <a:buChar char="•"/>
+            </a:pPr>
+            <a:r>
+              <a:rPr lang="en-HU" sz="1200" dirty="0"/>
+              <a:t>ThreadDialog</a:t>
+            </a:r>
+          </a:p>
+          <a:p>
+            <a:pPr marL="171450" indent="-171450">
+              <a:buFont typeface="Arial" panose="020B0604020202020204" pitchFamily="34" charset="0"/>
+              <a:buChar char="•"/>
+            </a:pPr>
+            <a:r>
+              <a:rPr lang="en-HU" sz="1200" dirty="0"/>
+              <a:t>(step, state)</a:t>
+            </a:r>
+          </a:p>
+        </p:txBody>
+      </p:sp>
+      <p:sp>
+        <p:nvSpPr>
+          <p:cNvPr id="5" name="Snip Single Corner of Rectangle 4">
+            <a:extLst>
+              <a:ext uri="{FF2B5EF4-FFF2-40B4-BE49-F238E27FC236}">
+                <a16:creationId xmlns:a16="http://schemas.microsoft.com/office/drawing/2014/main" id="{02F1D8F5-D99A-95CA-24FA-25FF75648F00}"/>
+              </a:ext>
+            </a:extLst>
+          </p:cNvPr>
+          <p:cNvSpPr/>
+          <p:nvPr/>
+        </p:nvSpPr>
+        <p:spPr>
+          <a:xfrm>
+            <a:off x="5816395" y="632356"/>
+            <a:ext cx="1602977" cy="1165973"/>
+          </a:xfrm>
+          <a:prstGeom prst="snip1Rect">
+            <a:avLst/>
+          </a:prstGeom>
+        </p:spPr>
+        <p:style>
+          <a:lnRef idx="2">
+            <a:schemeClr val="accent6"/>
+          </a:lnRef>
+          <a:fillRef idx="1">
+            <a:schemeClr val="lt1"/>
+          </a:fillRef>
+          <a:effectRef idx="0">
+            <a:schemeClr val="accent6"/>
+          </a:effectRef>
+          <a:fontRef idx="minor">
+            <a:schemeClr val="dk1"/>
+          </a:fontRef>
+        </p:style>
+        <p:txBody>
+          <a:bodyPr rtlCol="0" anchor="t"/>
+          <a:lstStyle/>
+          <a:p>
+            <a:r>
+              <a:rPr lang="en-HU" sz="1200" dirty="0"/>
+              <a:t>DialogIdea</a:t>
+            </a:r>
+          </a:p>
+          <a:p>
+            <a:pPr marL="171450" indent="-171450">
+              <a:buFont typeface="Arial" panose="020B0604020202020204" pitchFamily="34" charset="0"/>
+              <a:buChar char="•"/>
+            </a:pPr>
+            <a:r>
+              <a:rPr lang="en-HU" sz="1200" dirty="0"/>
+              <a:t>Logic (Machine)</a:t>
+            </a:r>
+          </a:p>
+          <a:p>
+            <a:pPr marL="171450" indent="-171450">
+              <a:buFont typeface="Arial" panose="020B0604020202020204" pitchFamily="34" charset="0"/>
+              <a:buChar char="•"/>
+            </a:pPr>
+            <a:r>
+              <a:rPr lang="en-HU" sz="1200" dirty="0"/>
+              <a:t>NextQueue</a:t>
+            </a:r>
+          </a:p>
+        </p:txBody>
+      </p:sp>
+      <p:sp>
+        <p:nvSpPr>
+          <p:cNvPr id="6" name="Snip Single Corner of Rectangle 5">
+            <a:extLst>
+              <a:ext uri="{FF2B5EF4-FFF2-40B4-BE49-F238E27FC236}">
+                <a16:creationId xmlns:a16="http://schemas.microsoft.com/office/drawing/2014/main" id="{B6DE702A-A174-582E-AE12-463014812480}"/>
+              </a:ext>
+            </a:extLst>
+          </p:cNvPr>
+          <p:cNvSpPr/>
+          <p:nvPr/>
+        </p:nvSpPr>
+        <p:spPr>
+          <a:xfrm>
+            <a:off x="1672658" y="4539949"/>
+            <a:ext cx="1477389" cy="1165973"/>
+          </a:xfrm>
+          <a:prstGeom prst="snip1Rect">
+            <a:avLst/>
+          </a:prstGeom>
+        </p:spPr>
+        <p:style>
+          <a:lnRef idx="2">
+            <a:schemeClr val="accent6"/>
+          </a:lnRef>
+          <a:fillRef idx="1">
+            <a:schemeClr val="lt1"/>
+          </a:fillRef>
+          <a:effectRef idx="0">
+            <a:schemeClr val="accent6"/>
+          </a:effectRef>
+          <a:fontRef idx="minor">
+            <a:schemeClr val="dk1"/>
+          </a:fontRef>
+        </p:style>
+        <p:txBody>
+          <a:bodyPr rtlCol="0" anchor="t"/>
+          <a:lstStyle/>
+          <a:p>
+            <a:r>
+              <a:rPr lang="en-HU" sz="1200" dirty="0"/>
+              <a:t>UnitIdea</a:t>
+            </a:r>
+          </a:p>
+          <a:p>
+            <a:pPr marL="171450" indent="-171450">
+              <a:buFont typeface="Arial" panose="020B0604020202020204" pitchFamily="34" charset="0"/>
+              <a:buChar char="•"/>
+            </a:pPr>
+            <a:r>
+              <a:rPr lang="en-HU" sz="1200" dirty="0"/>
+              <a:t>UnitHandles</a:t>
+            </a:r>
+          </a:p>
+          <a:p>
+            <a:pPr marL="171450" indent="-171450">
+              <a:buFont typeface="Arial" panose="020B0604020202020204" pitchFamily="34" charset="0"/>
+              <a:buChar char="•"/>
+            </a:pPr>
+            <a:r>
+              <a:rPr lang="en-HU" sz="1200" dirty="0"/>
+              <a:t>UnitIdeas</a:t>
+            </a:r>
+          </a:p>
+        </p:txBody>
+      </p:sp>
+    </p:spTree>
+    <p:extLst>
+      <p:ext uri="{BB962C8B-B14F-4D97-AF65-F5344CB8AC3E}">
+        <p14:creationId xmlns:p14="http://schemas.microsoft.com/office/powerpoint/2010/main" val="2435580554"/>
       </p:ext>
     </p:extLst>
   </p:cSld>

</xml_diff>